<commit_message>
Add rho explainer and curve-feature schematic slides
Pulls two slides forward from the prior SORMI deck: the Spearman /
LOFO-CV rho explainer (slide 11), placed ahead of the first slide that
quotes a rho, and the annotated resazurin curve schematic (slide 14),
placed ahead of the index feature table.

Co-Authored-By: Claude Opus 5 <noreply@anthropic.com>
</commit_message>
<xml_diff>
--- a/Future-Shellf-PCSGA-2026.pptx
+++ b/Future-Shellf-PCSGA-2026.pptx
@@ -23,6 +23,8 @@
     <p:sldId id="271" r:id="rId23"/>
     <p:sldId id="272" r:id="rId24"/>
     <p:sldId id="273" r:id="rId25"/>
+    <p:sldId id="274" r:id="rId26"/>
+    <p:sldId id="275" r:id="rId27"/>
   </p:sldIdLst>
   <p:sldSz cx="12191695" cy="6858000" type="screen4x3"/>
   <p:notesSz cx="6858000" cy="9144000"/>
@@ -589,7 +591,7 @@
           <a:lstStyle/>
           <a:p>
             <a:r>
-              <a:t>Leave-one-family-out CV is the honest number.</a:t>
+              <a:t>A small gap between the two means the prediction isn't just memorizing our nine families. Spend ~45 s here — every rho on the next three slides depends on it.</a:t>
             </a:r>
           </a:p>
         </p:txBody>
@@ -659,7 +661,7 @@
           <a:lstStyle/>
           <a:p>
             <a:r>
-              <a:t>Metabolic depression as a resilience strategy — consistent with the PeerJ survival result.</a:t>
+              <a:t>Leave-one-family-out CV is the honest number.</a:t>
             </a:r>
           </a:p>
         </p:txBody>
@@ -729,7 +731,7 @@
           <a:lstStyle/>
           <a:p>
             <a:r>
-              <a:t>Measured under freshwater + heat. Blending averages out individual noise.</a:t>
+              <a:t>Metabolic depression as a resilience strategy — consistent with the PeerJ survival result.</a:t>
             </a:r>
           </a:p>
         </p:txBody>
@@ -799,7 +801,7 @@
           <a:lstStyle/>
           <a:p>
             <a:r>
-              <a:t>Half a day of dye work stands in for a season of grow-out.</a:t>
+              <a:t>Walk the curve once: climbs, peaks, then drops. Early rise, steadiness, time to steepest drop, depth of collapse. Then the next slide says which direction is good.</a:t>
             </a:r>
           </a:p>
         </p:txBody>
@@ -869,7 +871,7 @@
           <a:lstStyle/>
           <a:p>
             <a:r>
-              <a:t>This is the operational pitch: early warning + management comparison.</a:t>
+              <a:t>Measured under freshwater + heat. Blending averages out individual noise.</a:t>
             </a:r>
           </a:p>
         </p:txBody>
@@ -939,7 +941,7 @@
           <a:lstStyle/>
           <a:p>
             <a:r>
-              <a:t>Short — leave time for questions.</a:t>
+              <a:t>Half a day of dye work stands in for a season of grow-out.</a:t>
             </a:r>
           </a:p>
         </p:txBody>
@@ -965,6 +967,146 @@
 </file>
 
 <file path=ppt/notesSlides/notesSlide16.xml><?xml version="1.0" encoding="utf-8"?>
+<p:notes xmlns:a="http://schemas.openxmlformats.org/drawingml/2006/main" xmlns:p="http://schemas.openxmlformats.org/presentationml/2006/main" xmlns:r="http://schemas.openxmlformats.org/officeDocument/2006/relationships">
+  <p:cSld>
+    <p:spTree>
+      <p:nvGrpSpPr>
+        <p:cNvPr id="1" name=""/>
+        <p:cNvGrpSpPr/>
+        <p:nvPr/>
+      </p:nvGrpSpPr>
+      <p:grpSpPr>
+        <a:xfrm>
+          <a:off x="0" y="0"/>
+          <a:ext cx="0" cy="0"/>
+          <a:chOff x="0" y="0"/>
+          <a:chExt cx="0" cy="0"/>
+        </a:xfrm>
+      </p:grpSpPr>
+      <p:sp>
+        <p:nvSpPr>
+          <p:cNvPr id="2" name="Slide Image Placeholder 1"/>
+          <p:cNvSpPr>
+            <a:spLocks noGrp="1"/>
+          </p:cNvSpPr>
+          <p:nvPr>
+            <p:ph type="sldImg" idx="2"/>
+          </p:nvPr>
+        </p:nvSpPr>
+        <p:spPr/>
+      </p:sp>
+      <p:sp>
+        <p:nvSpPr>
+          <p:cNvPr id="3" name="Notes Placeholder 2"/>
+          <p:cNvSpPr>
+            <a:spLocks noGrp="1"/>
+          </p:cNvSpPr>
+          <p:nvPr>
+            <p:ph type="body" idx="3" sz="quarter"/>
+          </p:nvPr>
+        </p:nvSpPr>
+        <p:spPr/>
+        <p:txBody>
+          <a:bodyPr/>
+          <a:lstStyle/>
+          <a:p>
+            <a:r>
+              <a:t>This is the operational pitch: early warning + management comparison.</a:t>
+            </a:r>
+          </a:p>
+        </p:txBody>
+      </p:sp>
+      <p:sp>
+        <p:nvSpPr>
+          <p:cNvPr id="4" name="Slide Number Placeholder 3"/>
+          <p:cNvSpPr>
+            <a:spLocks noGrp="1"/>
+          </p:cNvSpPr>
+          <p:nvPr>
+            <p:ph type="sldNum" idx="5" sz="quarter"/>
+          </p:nvPr>
+        </p:nvSpPr>
+        <p:spPr/>
+      </p:sp>
+    </p:spTree>
+  </p:cSld>
+  <p:clrMapOvr>
+    <a:masterClrMapping/>
+  </p:clrMapOvr>
+</p:notes>
+</file>
+
+<file path=ppt/notesSlides/notesSlide17.xml><?xml version="1.0" encoding="utf-8"?>
+<p:notes xmlns:a="http://schemas.openxmlformats.org/drawingml/2006/main" xmlns:p="http://schemas.openxmlformats.org/presentationml/2006/main" xmlns:r="http://schemas.openxmlformats.org/officeDocument/2006/relationships">
+  <p:cSld>
+    <p:spTree>
+      <p:nvGrpSpPr>
+        <p:cNvPr id="1" name=""/>
+        <p:cNvGrpSpPr/>
+        <p:nvPr/>
+      </p:nvGrpSpPr>
+      <p:grpSpPr>
+        <a:xfrm>
+          <a:off x="0" y="0"/>
+          <a:ext cx="0" cy="0"/>
+          <a:chOff x="0" y="0"/>
+          <a:chExt cx="0" cy="0"/>
+        </a:xfrm>
+      </p:grpSpPr>
+      <p:sp>
+        <p:nvSpPr>
+          <p:cNvPr id="2" name="Slide Image Placeholder 1"/>
+          <p:cNvSpPr>
+            <a:spLocks noGrp="1"/>
+          </p:cNvSpPr>
+          <p:nvPr>
+            <p:ph type="sldImg" idx="2"/>
+          </p:nvPr>
+        </p:nvSpPr>
+        <p:spPr/>
+      </p:sp>
+      <p:sp>
+        <p:nvSpPr>
+          <p:cNvPr id="3" name="Notes Placeholder 2"/>
+          <p:cNvSpPr>
+            <a:spLocks noGrp="1"/>
+          </p:cNvSpPr>
+          <p:nvPr>
+            <p:ph type="body" idx="3" sz="quarter"/>
+          </p:nvPr>
+        </p:nvSpPr>
+        <p:spPr/>
+        <p:txBody>
+          <a:bodyPr/>
+          <a:lstStyle/>
+          <a:p>
+            <a:r>
+              <a:t>Short — leave time for questions.</a:t>
+            </a:r>
+          </a:p>
+        </p:txBody>
+      </p:sp>
+      <p:sp>
+        <p:nvSpPr>
+          <p:cNvPr id="4" name="Slide Number Placeholder 3"/>
+          <p:cNvSpPr>
+            <a:spLocks noGrp="1"/>
+          </p:cNvSpPr>
+          <p:nvPr>
+            <p:ph type="sldNum" idx="5" sz="quarter"/>
+          </p:nvPr>
+        </p:nvSpPr>
+        <p:spPr/>
+      </p:sp>
+    </p:spTree>
+  </p:cSld>
+  <p:clrMapOvr>
+    <a:masterClrMapping/>
+  </p:clrMapOvr>
+</p:notes>
+</file>
+
+<file path=ppt/notesSlides/notesSlide18.xml><?xml version="1.0" encoding="utf-8"?>
 <p:notes xmlns:a="http://schemas.openxmlformats.org/drawingml/2006/main" xmlns:p="http://schemas.openxmlformats.org/presentationml/2006/main" xmlns:r="http://schemas.openxmlformats.org/officeDocument/2006/relationships">
   <p:cSld>
     <p:spTree>
@@ -4963,7 +5105,7 @@
               </a:defRPr>
             </a:pPr>
             <a:r>
-              <a:t>Tough families crash later</a:t>
+              <a:t>Reading the score: what the numbers mean</a:t>
             </a:r>
           </a:p>
         </p:txBody>
@@ -5042,45 +5184,21 @@
               </a:defRPr>
             </a:pPr>
             <a:r>
-              <a:t>Single best metabolic predictor</a:t>
-            </a:r>
-          </a:p>
-        </p:txBody>
-      </p:sp>
-      <p:pic>
-        <p:nvPicPr>
-          <p:cNvPr id="5" name="Picture 4" descr="best_single_predictor_scatter.png"/>
-          <p:cNvPicPr>
-            <a:picLocks noChangeAspect="1"/>
-          </p:cNvPicPr>
-          <p:nvPr/>
-        </p:nvPicPr>
-        <p:blipFill>
-          <a:blip r:embed="rId2"/>
-          <a:stretch>
-            <a:fillRect/>
-          </a:stretch>
-        </p:blipFill>
-        <p:spPr>
-          <a:xfrm>
-            <a:off x="1490472" y="2057400"/>
-            <a:ext cx="4587240" cy="3931920"/>
-          </a:xfrm>
-          <a:prstGeom prst="rect">
-            <a:avLst/>
-          </a:prstGeom>
-        </p:spPr>
-      </p:pic>
-      <p:sp>
-        <p:nvSpPr>
-          <p:cNvPr id="6" name="TextBox 5"/>
+              <a:t>Both numbers ask the same thing, on a scale of -1 to +1</a:t>
+            </a:r>
+          </a:p>
+        </p:txBody>
+      </p:sp>
+      <p:sp>
+        <p:nvSpPr>
+          <p:cNvPr id="5" name="TextBox 4"/>
           <p:cNvSpPr txBox="1"/>
           <p:nvPr/>
         </p:nvSpPr>
         <p:spPr>
           <a:xfrm>
-            <a:off x="7040880" y="1828800"/>
-            <a:ext cx="4480560" cy="4023360"/>
+            <a:off x="777240" y="2103120"/>
+            <a:ext cx="10607040" cy="548640"/>
           </a:xfrm>
           <a:prstGeom prst="rect">
             <a:avLst/>
@@ -5094,62 +5212,158 @@
           <a:lstStyle/>
           <a:p>
             <a:pPr>
+              <a:defRPr sz="2300" b="1">
+                <a:solidFill>
+                  <a:srgbClr val="1B3A5C"/>
+                </a:solidFill>
+              </a:defRPr>
+            </a:pPr>
+            <a:r>
+              <a:t>Does the test rank the families in their true survival order?</a:t>
+            </a:r>
+          </a:p>
+        </p:txBody>
+      </p:sp>
+      <p:sp>
+        <p:nvSpPr>
+          <p:cNvPr id="6" name="TextBox 5"/>
+          <p:cNvSpPr txBox="1"/>
+          <p:nvPr/>
+        </p:nvSpPr>
+        <p:spPr>
+          <a:xfrm>
+            <a:off x="777240" y="2788920"/>
+            <a:ext cx="10607040" cy="2651760"/>
+          </a:xfrm>
+          <a:prstGeom prst="rect">
+            <a:avLst/>
+          </a:prstGeom>
+          <a:noFill/>
+        </p:spPr>
+        <p:txBody>
+          <a:bodyPr wrap="square">
+            <a:spAutoFit/>
+          </a:bodyPr>
+          <a:lstStyle/>
+          <a:p>
+            <a:pPr>
+              <a:spcBef>
+                <a:spcPts val="1400"/>
+              </a:spcBef>
+              <a:defRPr sz="2100" b="1">
+                <a:solidFill>
+                  <a:srgbClr val="0E7C86"/>
+                </a:solidFill>
+              </a:defRPr>
+            </a:pPr>
+            <a:r>
+              <a:t>Spearman rho</a:t>
+            </a:r>
+          </a:p>
+          <a:p>
+            <a:pPr>
+              <a:spcBef>
+                <a:spcPts val="400"/>
+              </a:spcBef>
               <a:spcAft>
+                <a:spcPts val="1800"/>
+              </a:spcAft>
+              <a:defRPr sz="1800">
+                <a:solidFill>
+                  <a:srgbClr val="444A52"/>
+                </a:solidFill>
+              </a:defRPr>
+            </a:pPr>
+            <a:r>
+              <a:t>A ranking agreement score. +1 = same order (the test's toughest really is the toughest), 0 = unrelated, -1 = reversed. We rank rather than use raw values so one odd family can't distort it.</a:t>
+            </a:r>
+          </a:p>
+          <a:p>
+            <a:pPr>
+              <a:spcBef>
                 <a:spcPts val="1400"/>
+              </a:spcBef>
+              <a:defRPr sz="2100" b="1">
+                <a:solidFill>
+                  <a:srgbClr val="0E7C86"/>
+                </a:solidFill>
+              </a:defRPr>
+            </a:pPr>
+            <a:r>
+              <a:t>LOFO-CV rho</a:t>
+            </a:r>
+          </a:p>
+          <a:p>
+            <a:pPr>
+              <a:spcBef>
+                <a:spcPts val="400"/>
+              </a:spcBef>
+              <a:spcAft>
+                <a:spcPts val="1800"/>
               </a:spcAft>
-              <a:defRPr sz="1700">
+              <a:defRPr sz="1800">
                 <a:solidFill>
                   <a:srgbClr val="444A52"/>
                 </a:solidFill>
               </a:defRPr>
             </a:pPr>
             <a:r>
-              <a:t>• Each dot is a family.</a:t>
-            </a:r>
-          </a:p>
-          <a:p>
-            <a:pPr>
-              <a:spcAft>
-                <a:spcPts val="1400"/>
-              </a:spcAft>
-              <a:defRPr sz="1700">
-                <a:solidFill>
-                  <a:srgbClr val="444A52"/>
+              <a:t>The same score, measured honestly on families the model never saw: hide one family, predict it from the other eight, repeat for all nine, then compare.</a:t>
+            </a:r>
+          </a:p>
+        </p:txBody>
+      </p:sp>
+      <p:sp>
+        <p:nvSpPr>
+          <p:cNvPr id="7" name="Rectangle 6"/>
+          <p:cNvSpPr/>
+          <p:nvPr/>
+        </p:nvSpPr>
+        <p:spPr>
+          <a:xfrm>
+            <a:off x="777240" y="5623560"/>
+            <a:ext cx="10607040" cy="777240"/>
+          </a:xfrm>
+          <a:prstGeom prst="rect">
+            <a:avLst/>
+          </a:prstGeom>
+          <a:solidFill>
+            <a:srgbClr val="EFF3F6"/>
+          </a:solidFill>
+          <a:ln w="15875">
+            <a:solidFill>
+              <a:srgbClr val="0E7C86"/>
+            </a:solidFill>
+          </a:ln>
+          <a:effectLst/>
+        </p:spPr>
+        <p:style>
+          <a:lnRef idx="1">
+            <a:schemeClr val="accent1"/>
+          </a:lnRef>
+          <a:fillRef idx="3">
+            <a:schemeClr val="accent1"/>
+          </a:fillRef>
+          <a:effectRef idx="2">
+            <a:schemeClr val="accent1"/>
+          </a:effectRef>
+          <a:fontRef idx="minor">
+            <a:schemeClr val="lt1"/>
+          </a:fontRef>
+        </p:style>
+        <p:txBody>
+          <a:bodyPr rtlCol="0" anchor="ctr" wrap="square"/>
+          <a:lstStyle/>
+          <a:p>
+            <a:pPr algn="ctr">
+              <a:defRPr sz="1900" b="1">
+                <a:solidFill>
+                  <a:srgbClr val="1B3A5C"/>
                 </a:solidFill>
               </a:defRPr>
             </a:pPr>
             <a:r>
-              <a:t>• X: time to the steepest metabolic decline under freshwater + heat. Further right = crashes later.</a:t>
-            </a:r>
-          </a:p>
-          <a:p>
-            <a:pPr>
-              <a:spcAft>
-                <a:spcPts val="1400"/>
-              </a:spcAft>
-              <a:defRPr sz="1700">
-                <a:solidFill>
-                  <a:srgbClr val="444A52"/>
-                </a:solidFill>
-              </a:defRPr>
-            </a:pPr>
-            <a:r>
-              <a:t>• Y: survival score (higher = tougher).</a:t>
-            </a:r>
-          </a:p>
-          <a:p>
-            <a:pPr>
-              <a:spcAft>
-                <a:spcPts val="1400"/>
-              </a:spcAft>
-              <a:defRPr sz="1700">
-                <a:solidFill>
-                  <a:srgbClr val="444A52"/>
-                </a:solidFill>
-              </a:defRPr>
-            </a:pPr>
-            <a:r>
-              <a:t>• rho = 0.90; cross-validated rho = 0.81 when each family is predicted from the other eight.</a:t>
+              <a:t>Spearman rho = optimistic best case.  LOFO-CV rho = the trustworthy one.</a:t>
             </a:r>
           </a:p>
         </p:txBody>
@@ -5202,7 +5416,7 @@
               </a:defRPr>
             </a:pPr>
             <a:r>
-              <a:t>The counterintuitive part</a:t>
+              <a:t>Tough families crash later</a:t>
             </a:r>
           </a:p>
         </p:txBody>
@@ -5281,21 +5495,45 @@
               </a:defRPr>
             </a:pPr>
             <a:r>
-              <a:t>Hardy oysters stay calm</a:t>
-            </a:r>
-          </a:p>
-        </p:txBody>
-      </p:sp>
-      <p:sp>
-        <p:nvSpPr>
-          <p:cNvPr id="5" name="TextBox 4"/>
+              <a:t>Single best metabolic predictor</a:t>
+            </a:r>
+          </a:p>
+        </p:txBody>
+      </p:sp>
+      <p:pic>
+        <p:nvPicPr>
+          <p:cNvPr id="5" name="Picture 4" descr="best_single_predictor_scatter.png"/>
+          <p:cNvPicPr>
+            <a:picLocks noChangeAspect="1"/>
+          </p:cNvPicPr>
+          <p:nvPr/>
+        </p:nvPicPr>
+        <p:blipFill>
+          <a:blip r:embed="rId2"/>
+          <a:stretch>
+            <a:fillRect/>
+          </a:stretch>
+        </p:blipFill>
+        <p:spPr>
+          <a:xfrm>
+            <a:off x="1490472" y="2057400"/>
+            <a:ext cx="4587240" cy="3931920"/>
+          </a:xfrm>
+          <a:prstGeom prst="rect">
+            <a:avLst/>
+          </a:prstGeom>
+        </p:spPr>
+      </p:pic>
+      <p:sp>
+        <p:nvSpPr>
+          <p:cNvPr id="6" name="TextBox 5"/>
           <p:cNvSpPr txBox="1"/>
           <p:nvPr/>
         </p:nvSpPr>
         <p:spPr>
           <a:xfrm>
-            <a:off x="777240" y="2286000"/>
-            <a:ext cx="10607040" cy="4206240"/>
+            <a:off x="7040880" y="1828800"/>
+            <a:ext cx="4480560" cy="4023360"/>
           </a:xfrm>
           <a:prstGeom prst="rect">
             <a:avLst/>
@@ -5310,61 +5548,61 @@
           <a:p>
             <a:pPr>
               <a:spcAft>
-                <a:spcPts val="2400"/>
+                <a:spcPts val="1400"/>
               </a:spcAft>
-              <a:defRPr sz="2400">
-                <a:solidFill>
-                  <a:srgbClr val="22262B"/>
+              <a:defRPr sz="1700">
+                <a:solidFill>
+                  <a:srgbClr val="444A52"/>
                 </a:solidFill>
               </a:defRPr>
             </a:pPr>
             <a:r>
-              <a:t>• Families whose metabolism spikes hardest when heated survive the least.</a:t>
+              <a:t>• Each dot is a family.</a:t>
             </a:r>
           </a:p>
           <a:p>
             <a:pPr>
               <a:spcAft>
-                <a:spcPts val="2400"/>
+                <a:spcPts val="1400"/>
               </a:spcAft>
-              <a:defRPr sz="2400">
-                <a:solidFill>
-                  <a:srgbClr val="22262B"/>
+              <a:defRPr sz="1700">
+                <a:solidFill>
+                  <a:srgbClr val="444A52"/>
                 </a:solidFill>
               </a:defRPr>
             </a:pPr>
             <a:r>
-              <a:t>• Hardy families keep metabolism restrained — they don't overreact.</a:t>
+              <a:t>• X: time to the steepest metabolic decline under freshwater + heat. Further right = crashes later.</a:t>
             </a:r>
           </a:p>
           <a:p>
             <a:pPr>
               <a:spcAft>
-                <a:spcPts val="2400"/>
+                <a:spcPts val="1400"/>
               </a:spcAft>
-              <a:defRPr sz="2400">
-                <a:solidFill>
-                  <a:srgbClr val="22262B"/>
+              <a:defRPr sz="1700">
+                <a:solidFill>
+                  <a:srgbClr val="444A52"/>
                 </a:solidFill>
               </a:defRPr>
             </a:pPr>
             <a:r>
-              <a:t>• They decline slowly and late rather than crashing early.</a:t>
+              <a:t>• Y: survival score (higher = tougher).</a:t>
             </a:r>
           </a:p>
           <a:p>
             <a:pPr>
               <a:spcAft>
-                <a:spcPts val="2400"/>
+                <a:spcPts val="1400"/>
               </a:spcAft>
-              <a:defRPr sz="2400">
-                <a:solidFill>
-                  <a:srgbClr val="22262B"/>
+              <a:defRPr sz="1700">
+                <a:solidFill>
+                  <a:srgbClr val="444A52"/>
                 </a:solidFill>
               </a:defRPr>
             </a:pPr>
             <a:r>
-              <a:t>• The signal is strongest when the assay is run during stress, not at rest.</a:t>
+              <a:t>• rho = 0.90; cross-validated rho = 0.81 when each family is predicted from the other eight.</a:t>
             </a:r>
           </a:p>
         </p:txBody>
@@ -5378,6 +5616,377 @@
 </file>
 
 <file path=ppt/slides/slide13.xml><?xml version="1.0" encoding="utf-8"?>
+<p:sld xmlns:a="http://schemas.openxmlformats.org/drawingml/2006/main" xmlns:p="http://schemas.openxmlformats.org/presentationml/2006/main" xmlns:r="http://schemas.openxmlformats.org/officeDocument/2006/relationships">
+  <p:cSld>
+    <p:spTree>
+      <p:nvGrpSpPr>
+        <p:cNvPr id="1" name=""/>
+        <p:cNvGrpSpPr/>
+        <p:nvPr/>
+      </p:nvGrpSpPr>
+      <p:grpSpPr/>
+      <p:sp>
+        <p:nvSpPr>
+          <p:cNvPr id="2" name="TextBox 1"/>
+          <p:cNvSpPr txBox="1"/>
+          <p:nvPr/>
+        </p:nvSpPr>
+        <p:spPr>
+          <a:xfrm>
+            <a:off x="640080" y="411480"/>
+            <a:ext cx="10881360" cy="914400"/>
+          </a:xfrm>
+          <a:prstGeom prst="rect">
+            <a:avLst/>
+          </a:prstGeom>
+          <a:noFill/>
+        </p:spPr>
+        <p:txBody>
+          <a:bodyPr wrap="square">
+            <a:spAutoFit/>
+          </a:bodyPr>
+          <a:lstStyle/>
+          <a:p>
+            <a:pPr>
+              <a:defRPr sz="3400" b="1">
+                <a:solidFill>
+                  <a:srgbClr val="1B3A5C"/>
+                </a:solidFill>
+              </a:defRPr>
+            </a:pPr>
+            <a:r>
+              <a:t>The counterintuitive part</a:t>
+            </a:r>
+          </a:p>
+        </p:txBody>
+      </p:sp>
+      <p:sp>
+        <p:nvSpPr>
+          <p:cNvPr id="3" name="Rectangle 2"/>
+          <p:cNvSpPr/>
+          <p:nvPr/>
+        </p:nvSpPr>
+        <p:spPr>
+          <a:xfrm>
+            <a:off x="640080" y="1325880"/>
+            <a:ext cx="1463040" cy="54864"/>
+          </a:xfrm>
+          <a:prstGeom prst="rect">
+            <a:avLst/>
+          </a:prstGeom>
+          <a:solidFill>
+            <a:srgbClr val="0E7C86"/>
+          </a:solidFill>
+          <a:ln>
+            <a:noFill/>
+          </a:ln>
+          <a:effectLst/>
+        </p:spPr>
+        <p:style>
+          <a:lnRef idx="1">
+            <a:schemeClr val="accent1"/>
+          </a:lnRef>
+          <a:fillRef idx="3">
+            <a:schemeClr val="accent1"/>
+          </a:fillRef>
+          <a:effectRef idx="2">
+            <a:schemeClr val="accent1"/>
+          </a:effectRef>
+          <a:fontRef idx="minor">
+            <a:schemeClr val="lt1"/>
+          </a:fontRef>
+        </p:style>
+        <p:txBody>
+          <a:bodyPr rtlCol="0" anchor="ctr"/>
+          <a:lstStyle/>
+          <a:p>
+            <a:pPr algn="ctr"/>
+          </a:p>
+        </p:txBody>
+      </p:sp>
+      <p:sp>
+        <p:nvSpPr>
+          <p:cNvPr id="4" name="TextBox 3"/>
+          <p:cNvSpPr txBox="1"/>
+          <p:nvPr/>
+        </p:nvSpPr>
+        <p:spPr>
+          <a:xfrm>
+            <a:off x="640080" y="1463040"/>
+            <a:ext cx="10881360" cy="457200"/>
+          </a:xfrm>
+          <a:prstGeom prst="rect">
+            <a:avLst/>
+          </a:prstGeom>
+          <a:noFill/>
+        </p:spPr>
+        <p:txBody>
+          <a:bodyPr wrap="square">
+            <a:spAutoFit/>
+          </a:bodyPr>
+          <a:lstStyle/>
+          <a:p>
+            <a:pPr>
+              <a:defRPr sz="1800" i="1">
+                <a:solidFill>
+                  <a:srgbClr val="0E7C86"/>
+                </a:solidFill>
+              </a:defRPr>
+            </a:pPr>
+            <a:r>
+              <a:t>Hardy oysters stay calm</a:t>
+            </a:r>
+          </a:p>
+        </p:txBody>
+      </p:sp>
+      <p:sp>
+        <p:nvSpPr>
+          <p:cNvPr id="5" name="TextBox 4"/>
+          <p:cNvSpPr txBox="1"/>
+          <p:nvPr/>
+        </p:nvSpPr>
+        <p:spPr>
+          <a:xfrm>
+            <a:off x="777240" y="2286000"/>
+            <a:ext cx="10607040" cy="4206240"/>
+          </a:xfrm>
+          <a:prstGeom prst="rect">
+            <a:avLst/>
+          </a:prstGeom>
+          <a:noFill/>
+        </p:spPr>
+        <p:txBody>
+          <a:bodyPr wrap="square">
+            <a:spAutoFit/>
+          </a:bodyPr>
+          <a:lstStyle/>
+          <a:p>
+            <a:pPr>
+              <a:spcAft>
+                <a:spcPts val="2400"/>
+              </a:spcAft>
+              <a:defRPr sz="2400">
+                <a:solidFill>
+                  <a:srgbClr val="22262B"/>
+                </a:solidFill>
+              </a:defRPr>
+            </a:pPr>
+            <a:r>
+              <a:t>• Families whose metabolism spikes hardest when heated survive the least.</a:t>
+            </a:r>
+          </a:p>
+          <a:p>
+            <a:pPr>
+              <a:spcAft>
+                <a:spcPts val="2400"/>
+              </a:spcAft>
+              <a:defRPr sz="2400">
+                <a:solidFill>
+                  <a:srgbClr val="22262B"/>
+                </a:solidFill>
+              </a:defRPr>
+            </a:pPr>
+            <a:r>
+              <a:t>• Hardy families keep metabolism restrained — they don't overreact.</a:t>
+            </a:r>
+          </a:p>
+          <a:p>
+            <a:pPr>
+              <a:spcAft>
+                <a:spcPts val="2400"/>
+              </a:spcAft>
+              <a:defRPr sz="2400">
+                <a:solidFill>
+                  <a:srgbClr val="22262B"/>
+                </a:solidFill>
+              </a:defRPr>
+            </a:pPr>
+            <a:r>
+              <a:t>• They decline slowly and late rather than crashing early.</a:t>
+            </a:r>
+          </a:p>
+          <a:p>
+            <a:pPr>
+              <a:spcAft>
+                <a:spcPts val="2400"/>
+              </a:spcAft>
+              <a:defRPr sz="2400">
+                <a:solidFill>
+                  <a:srgbClr val="22262B"/>
+                </a:solidFill>
+              </a:defRPr>
+            </a:pPr>
+            <a:r>
+              <a:t>• The signal is strongest when the assay is run during stress, not at rest.</a:t>
+            </a:r>
+          </a:p>
+        </p:txBody>
+      </p:sp>
+    </p:spTree>
+  </p:cSld>
+  <p:clrMapOvr>
+    <a:masterClrMapping/>
+  </p:clrMapOvr>
+</p:sld>
+</file>
+
+<file path=ppt/slides/slide14.xml><?xml version="1.0" encoding="utf-8"?>
+<p:sld xmlns:a="http://schemas.openxmlformats.org/drawingml/2006/main" xmlns:p="http://schemas.openxmlformats.org/presentationml/2006/main" xmlns:r="http://schemas.openxmlformats.org/officeDocument/2006/relationships">
+  <p:cSld>
+    <p:spTree>
+      <p:nvGrpSpPr>
+        <p:cNvPr id="1" name=""/>
+        <p:cNvGrpSpPr/>
+        <p:nvPr/>
+      </p:nvGrpSpPr>
+      <p:grpSpPr/>
+      <p:sp>
+        <p:nvSpPr>
+          <p:cNvPr id="2" name="TextBox 1"/>
+          <p:cNvSpPr txBox="1"/>
+          <p:nvPr/>
+        </p:nvSpPr>
+        <p:spPr>
+          <a:xfrm>
+            <a:off x="640080" y="411480"/>
+            <a:ext cx="10881360" cy="914400"/>
+          </a:xfrm>
+          <a:prstGeom prst="rect">
+            <a:avLst/>
+          </a:prstGeom>
+          <a:noFill/>
+        </p:spPr>
+        <p:txBody>
+          <a:bodyPr wrap="square">
+            <a:spAutoFit/>
+          </a:bodyPr>
+          <a:lstStyle/>
+          <a:p>
+            <a:pPr>
+              <a:defRPr sz="3400" b="1">
+                <a:solidFill>
+                  <a:srgbClr val="1B3A5C"/>
+                </a:solidFill>
+              </a:defRPr>
+            </a:pPr>
+            <a:r>
+              <a:t>Four values read from one curve</a:t>
+            </a:r>
+          </a:p>
+        </p:txBody>
+      </p:sp>
+      <p:sp>
+        <p:nvSpPr>
+          <p:cNvPr id="3" name="Rectangle 2"/>
+          <p:cNvSpPr/>
+          <p:nvPr/>
+        </p:nvSpPr>
+        <p:spPr>
+          <a:xfrm>
+            <a:off x="640080" y="1325880"/>
+            <a:ext cx="1463040" cy="54864"/>
+          </a:xfrm>
+          <a:prstGeom prst="rect">
+            <a:avLst/>
+          </a:prstGeom>
+          <a:solidFill>
+            <a:srgbClr val="0E7C86"/>
+          </a:solidFill>
+          <a:ln>
+            <a:noFill/>
+          </a:ln>
+          <a:effectLst/>
+        </p:spPr>
+        <p:style>
+          <a:lnRef idx="1">
+            <a:schemeClr val="accent1"/>
+          </a:lnRef>
+          <a:fillRef idx="3">
+            <a:schemeClr val="accent1"/>
+          </a:fillRef>
+          <a:effectRef idx="2">
+            <a:schemeClr val="accent1"/>
+          </a:effectRef>
+          <a:fontRef idx="minor">
+            <a:schemeClr val="lt1"/>
+          </a:fontRef>
+        </p:style>
+        <p:txBody>
+          <a:bodyPr rtlCol="0" anchor="ctr"/>
+          <a:lstStyle/>
+          <a:p>
+            <a:pPr algn="ctr"/>
+          </a:p>
+        </p:txBody>
+      </p:sp>
+      <p:sp>
+        <p:nvSpPr>
+          <p:cNvPr id="4" name="TextBox 3"/>
+          <p:cNvSpPr txBox="1"/>
+          <p:nvPr/>
+        </p:nvSpPr>
+        <p:spPr>
+          <a:xfrm>
+            <a:off x="640080" y="1463040"/>
+            <a:ext cx="10881360" cy="457200"/>
+          </a:xfrm>
+          <a:prstGeom prst="rect">
+            <a:avLst/>
+          </a:prstGeom>
+          <a:noFill/>
+        </p:spPr>
+        <p:txBody>
+          <a:bodyPr wrap="square">
+            <a:spAutoFit/>
+          </a:bodyPr>
+          <a:lstStyle/>
+          <a:p>
+            <a:pPr>
+              <a:defRPr sz="1800" i="1">
+                <a:solidFill>
+                  <a:srgbClr val="0E7C86"/>
+                </a:solidFill>
+              </a:defRPr>
+            </a:pPr>
+            <a:r>
+              <a:t>Everything in the index comes from the shape of a single oyster's run</a:t>
+            </a:r>
+          </a:p>
+        </p:txBody>
+      </p:sp>
+      <p:pic>
+        <p:nvPicPr>
+          <p:cNvPr id="5" name="Picture 4" descr="index_feature_schematic.png"/>
+          <p:cNvPicPr>
+            <a:picLocks noChangeAspect="1"/>
+          </p:cNvPicPr>
+          <p:nvPr/>
+        </p:nvPicPr>
+        <p:blipFill>
+          <a:blip r:embed="rId2"/>
+          <a:stretch>
+            <a:fillRect/>
+          </a:stretch>
+        </p:blipFill>
+        <p:spPr>
+          <a:xfrm>
+            <a:off x="3032760" y="1828800"/>
+            <a:ext cx="6096000" cy="3657600"/>
+          </a:xfrm>
+          <a:prstGeom prst="rect">
+            <a:avLst/>
+          </a:prstGeom>
+        </p:spPr>
+      </p:pic>
+    </p:spTree>
+  </p:cSld>
+  <p:clrMapOvr>
+    <a:masterClrMapping/>
+  </p:clrMapOvr>
+</p:sld>
+</file>
+
+<file path=ppt/slides/slide15.xml><?xml version="1.0" encoding="utf-8"?>
 <p:sld xmlns:a="http://schemas.openxmlformats.org/drawingml/2006/main" xmlns:p="http://schemas.openxmlformats.org/presentationml/2006/main" xmlns:r="http://schemas.openxmlformats.org/officeDocument/2006/relationships">
   <p:cSld>
     <p:spTree>
@@ -5806,7 +6415,7 @@
 </p:sld>
 </file>
 
-<file path=ppt/slides/slide14.xml><?xml version="1.0" encoding="utf-8"?>
+<file path=ppt/slides/slide16.xml><?xml version="1.0" encoding="utf-8"?>
 <p:sld xmlns:a="http://schemas.openxmlformats.org/drawingml/2006/main" xmlns:p="http://schemas.openxmlformats.org/presentationml/2006/main" xmlns:r="http://schemas.openxmlformats.org/officeDocument/2006/relationships">
   <p:cSld>
     <p:spTree>
@@ -5998,403 +6607,6 @@
             </a:pPr>
             <a:r>
               <a:t>• Toughest (5) and most fragile (7) land at opposite ends.</a:t>
-            </a:r>
-          </a:p>
-        </p:txBody>
-      </p:sp>
-    </p:spTree>
-  </p:cSld>
-  <p:clrMapOvr>
-    <a:masterClrMapping/>
-  </p:clrMapOvr>
-</p:sld>
-</file>
-
-<file path=ppt/slides/slide15.xml><?xml version="1.0" encoding="utf-8"?>
-<p:sld xmlns:a="http://schemas.openxmlformats.org/drawingml/2006/main" xmlns:p="http://schemas.openxmlformats.org/presentationml/2006/main" xmlns:r="http://schemas.openxmlformats.org/officeDocument/2006/relationships">
-  <p:cSld>
-    <p:spTree>
-      <p:nvGrpSpPr>
-        <p:cNvPr id="1" name=""/>
-        <p:cNvGrpSpPr/>
-        <p:nvPr/>
-      </p:nvGrpSpPr>
-      <p:grpSpPr/>
-      <p:sp>
-        <p:nvSpPr>
-          <p:cNvPr id="2" name="Rectangle 1"/>
-          <p:cNvSpPr/>
-          <p:nvPr/>
-        </p:nvSpPr>
-        <p:spPr>
-          <a:xfrm>
-            <a:off x="0" y="0"/>
-            <a:ext cx="12191695" cy="6858000"/>
-          </a:xfrm>
-          <a:prstGeom prst="rect">
-            <a:avLst/>
-          </a:prstGeom>
-          <a:solidFill>
-            <a:srgbClr val="1B3A5C"/>
-          </a:solidFill>
-          <a:ln>
-            <a:noFill/>
-          </a:ln>
-          <a:effectLst/>
-        </p:spPr>
-        <p:style>
-          <a:lnRef idx="1">
-            <a:schemeClr val="accent1"/>
-          </a:lnRef>
-          <a:fillRef idx="3">
-            <a:schemeClr val="accent1"/>
-          </a:fillRef>
-          <a:effectRef idx="2">
-            <a:schemeClr val="accent1"/>
-          </a:effectRef>
-          <a:fontRef idx="minor">
-            <a:schemeClr val="lt1"/>
-          </a:fontRef>
-        </p:style>
-        <p:txBody>
-          <a:bodyPr rtlCol="0" anchor="ctr"/>
-          <a:lstStyle/>
-          <a:p>
-            <a:pPr algn="ctr"/>
-          </a:p>
-        </p:txBody>
-      </p:sp>
-      <p:sp>
-        <p:nvSpPr>
-          <p:cNvPr id="3" name="TextBox 2"/>
-          <p:cNvSpPr txBox="1"/>
-          <p:nvPr/>
-        </p:nvSpPr>
-        <p:spPr>
-          <a:xfrm>
-            <a:off x="1097280" y="2651760"/>
-            <a:ext cx="10058400" cy="1463040"/>
-          </a:xfrm>
-          <a:prstGeom prst="rect">
-            <a:avLst/>
-          </a:prstGeom>
-          <a:noFill/>
-        </p:spPr>
-        <p:txBody>
-          <a:bodyPr wrap="square">
-            <a:spAutoFit/>
-          </a:bodyPr>
-          <a:lstStyle/>
-          <a:p>
-            <a:pPr>
-              <a:defRPr sz="4000" b="1">
-                <a:solidFill>
-                  <a:srgbClr val="FFFFFF"/>
-                </a:solidFill>
-              </a:defRPr>
-            </a:pPr>
-            <a:r>
-              <a:t>Use #2 — Real-time stress on the farm</a:t>
-            </a:r>
-          </a:p>
-          <a:p>
-            <a:pPr>
-              <a:spcBef>
-                <a:spcPts val="1000"/>
-              </a:spcBef>
-              <a:defRPr sz="2000">
-                <a:solidFill>
-                  <a:srgbClr val="9FD3D8"/>
-                </a:solidFill>
-              </a:defRPr>
-            </a:pPr>
-            <a:r>
-              <a:t>A thermometer for physiological condition</a:t>
-            </a:r>
-          </a:p>
-        </p:txBody>
-      </p:sp>
-    </p:spTree>
-  </p:cSld>
-  <p:clrMapOvr>
-    <a:masterClrMapping/>
-  </p:clrMapOvr>
-</p:sld>
-</file>
-
-<file path=ppt/slides/slide16.xml><?xml version="1.0" encoding="utf-8"?>
-<p:sld xmlns:a="http://schemas.openxmlformats.org/drawingml/2006/main" xmlns:p="http://schemas.openxmlformats.org/presentationml/2006/main" xmlns:r="http://schemas.openxmlformats.org/officeDocument/2006/relationships">
-  <p:cSld>
-    <p:spTree>
-      <p:nvGrpSpPr>
-        <p:cNvPr id="1" name=""/>
-        <p:cNvGrpSpPr/>
-        <p:nvPr/>
-      </p:nvGrpSpPr>
-      <p:grpSpPr/>
-      <p:sp>
-        <p:nvSpPr>
-          <p:cNvPr id="2" name="TextBox 1"/>
-          <p:cNvSpPr txBox="1"/>
-          <p:nvPr/>
-        </p:nvSpPr>
-        <p:spPr>
-          <a:xfrm>
-            <a:off x="640080" y="411480"/>
-            <a:ext cx="10881360" cy="914400"/>
-          </a:xfrm>
-          <a:prstGeom prst="rect">
-            <a:avLst/>
-          </a:prstGeom>
-          <a:noFill/>
-        </p:spPr>
-        <p:txBody>
-          <a:bodyPr wrap="square">
-            <a:spAutoFit/>
-          </a:bodyPr>
-          <a:lstStyle/>
-          <a:p>
-            <a:pPr>
-              <a:defRPr sz="3400" b="1">
-                <a:solidFill>
-                  <a:srgbClr val="1B3A5C"/>
-                </a:solidFill>
-              </a:defRPr>
-            </a:pPr>
-            <a:r>
-              <a:t>Reading stress while it's happening</a:t>
-            </a:r>
-          </a:p>
-        </p:txBody>
-      </p:sp>
-      <p:sp>
-        <p:nvSpPr>
-          <p:cNvPr id="3" name="Rectangle 2"/>
-          <p:cNvSpPr/>
-          <p:nvPr/>
-        </p:nvSpPr>
-        <p:spPr>
-          <a:xfrm>
-            <a:off x="640080" y="1325880"/>
-            <a:ext cx="1463040" cy="54864"/>
-          </a:xfrm>
-          <a:prstGeom prst="rect">
-            <a:avLst/>
-          </a:prstGeom>
-          <a:solidFill>
-            <a:srgbClr val="0E7C86"/>
-          </a:solidFill>
-          <a:ln>
-            <a:noFill/>
-          </a:ln>
-          <a:effectLst/>
-        </p:spPr>
-        <p:style>
-          <a:lnRef idx="1">
-            <a:schemeClr val="accent1"/>
-          </a:lnRef>
-          <a:fillRef idx="3">
-            <a:schemeClr val="accent1"/>
-          </a:fillRef>
-          <a:effectRef idx="2">
-            <a:schemeClr val="accent1"/>
-          </a:effectRef>
-          <a:fontRef idx="minor">
-            <a:schemeClr val="lt1"/>
-          </a:fontRef>
-        </p:style>
-        <p:txBody>
-          <a:bodyPr rtlCol="0" anchor="ctr"/>
-          <a:lstStyle/>
-          <a:p>
-            <a:pPr algn="ctr"/>
-          </a:p>
-        </p:txBody>
-      </p:sp>
-      <p:sp>
-        <p:nvSpPr>
-          <p:cNvPr id="4" name="TextBox 3"/>
-          <p:cNvSpPr txBox="1"/>
-          <p:nvPr/>
-        </p:nvSpPr>
-        <p:spPr>
-          <a:xfrm>
-            <a:off x="640080" y="1463040"/>
-            <a:ext cx="10881360" cy="457200"/>
-          </a:xfrm>
-          <a:prstGeom prst="rect">
-            <a:avLst/>
-          </a:prstGeom>
-          <a:noFill/>
-        </p:spPr>
-        <p:txBody>
-          <a:bodyPr wrap="square">
-            <a:spAutoFit/>
-          </a:bodyPr>
-          <a:lstStyle/>
-          <a:p>
-            <a:pPr>
-              <a:defRPr sz="1800" i="1">
-                <a:solidFill>
-                  <a:srgbClr val="0E7C86"/>
-                </a:solidFill>
-              </a:defRPr>
-            </a:pPr>
-            <a:r>
-              <a:t>Same assay, different question</a:t>
-            </a:r>
-          </a:p>
-        </p:txBody>
-      </p:sp>
-      <p:sp>
-        <p:nvSpPr>
-          <p:cNvPr id="5" name="TextBox 4"/>
-          <p:cNvSpPr txBox="1"/>
-          <p:nvPr/>
-        </p:nvSpPr>
-        <p:spPr>
-          <a:xfrm>
-            <a:off x="777240" y="2148840"/>
-            <a:ext cx="10607040" cy="4206240"/>
-          </a:xfrm>
-          <a:prstGeom prst="rect">
-            <a:avLst/>
-          </a:prstGeom>
-          <a:noFill/>
-        </p:spPr>
-        <p:txBody>
-          <a:bodyPr wrap="square">
-            <a:spAutoFit/>
-          </a:bodyPr>
-          <a:lstStyle/>
-          <a:p>
-            <a:pPr>
-              <a:spcAft>
-                <a:spcPts val="1600"/>
-              </a:spcAft>
-              <a:defRPr sz="2100">
-                <a:solidFill>
-                  <a:srgbClr val="22262B"/>
-                </a:solidFill>
-              </a:defRPr>
-            </a:pPr>
-            <a:r>
-              <a:t>• Pull a small sample of animals, run a plate, get an answer the same day.</a:t>
-            </a:r>
-          </a:p>
-          <a:p>
-            <a:pPr>
-              <a:spcAft>
-                <a:spcPts val="1600"/>
-              </a:spcAft>
-              <a:defRPr sz="2100">
-                <a:solidFill>
-                  <a:srgbClr val="22262B"/>
-                </a:solidFill>
-              </a:defRPr>
-            </a:pPr>
-            <a:r>
-              <a:t>• Elevated metabolism under a heat or salinity event flags a crop under load — before mortality shows up.</a:t>
-            </a:r>
-          </a:p>
-          <a:p>
-            <a:pPr>
-              <a:spcAft>
-                <a:spcPts val="1600"/>
-              </a:spcAft>
-              <a:defRPr sz="2100">
-                <a:solidFill>
-                  <a:srgbClr val="22262B"/>
-                </a:solidFill>
-              </a:defRPr>
-            </a:pPr>
-            <a:r>
-              <a:t>• Compare bags, tidal heights, gear types, or sites on the same afternoon.</a:t>
-            </a:r>
-          </a:p>
-          <a:p>
-            <a:pPr>
-              <a:spcAft>
-                <a:spcPts val="1600"/>
-              </a:spcAft>
-              <a:defRPr sz="2100">
-                <a:solidFill>
-                  <a:srgbClr val="22262B"/>
-                </a:solidFill>
-              </a:defRPr>
-            </a:pPr>
-            <a:r>
-              <a:t>• Track recovery after an event: does metabolism return to baseline, and how fast?</a:t>
-            </a:r>
-          </a:p>
-          <a:p>
-            <a:pPr>
-              <a:spcAft>
-                <a:spcPts val="1600"/>
-              </a:spcAft>
-              <a:defRPr sz="2100">
-                <a:solidFill>
-                  <a:srgbClr val="22262B"/>
-                </a:solidFill>
-              </a:defRPr>
-            </a:pPr>
-            <a:r>
-              <a:t>• Non-lethal and cheap enough to repeat weekly through a risky season.</a:t>
-            </a:r>
-          </a:p>
-        </p:txBody>
-      </p:sp>
-      <p:sp>
-        <p:nvSpPr>
-          <p:cNvPr id="6" name="Rectangle 5"/>
-          <p:cNvSpPr/>
-          <p:nvPr/>
-        </p:nvSpPr>
-        <p:spPr>
-          <a:xfrm>
-            <a:off x="777240" y="5623560"/>
-            <a:ext cx="10607040" cy="777240"/>
-          </a:xfrm>
-          <a:prstGeom prst="rect">
-            <a:avLst/>
-          </a:prstGeom>
-          <a:solidFill>
-            <a:srgbClr val="EFF3F6"/>
-          </a:solidFill>
-          <a:ln w="15875">
-            <a:solidFill>
-              <a:srgbClr val="C2187A"/>
-            </a:solidFill>
-          </a:ln>
-          <a:effectLst/>
-        </p:spPr>
-        <p:style>
-          <a:lnRef idx="1">
-            <a:schemeClr val="accent1"/>
-          </a:lnRef>
-          <a:fillRef idx="3">
-            <a:schemeClr val="accent1"/>
-          </a:fillRef>
-          <a:effectRef idx="2">
-            <a:schemeClr val="accent1"/>
-          </a:effectRef>
-          <a:fontRef idx="minor">
-            <a:schemeClr val="lt1"/>
-          </a:fontRef>
-        </p:style>
-        <p:txBody>
-          <a:bodyPr rtlCol="0" anchor="ctr" wrap="square"/>
-          <a:lstStyle/>
-          <a:p>
-            <a:pPr algn="ctr">
-              <a:defRPr sz="1900" b="1">
-                <a:solidFill>
-                  <a:srgbClr val="1B3A5C"/>
-                </a:solidFill>
-              </a:defRPr>
-            </a:pPr>
-            <a:r>
-              <a:t>Turns "the water got hot last week" into a number you can act on.</a:t>
             </a:r>
           </a:p>
         </p:txBody>
@@ -6419,55 +6631,20 @@
       <p:grpSpPr/>
       <p:sp>
         <p:nvSpPr>
-          <p:cNvPr id="2" name="TextBox 1"/>
-          <p:cNvSpPr txBox="1"/>
-          <p:nvPr/>
-        </p:nvSpPr>
-        <p:spPr>
-          <a:xfrm>
-            <a:off x="640080" y="411480"/>
-            <a:ext cx="10881360" cy="914400"/>
-          </a:xfrm>
-          <a:prstGeom prst="rect">
-            <a:avLst/>
-          </a:prstGeom>
-          <a:noFill/>
-        </p:spPr>
-        <p:txBody>
-          <a:bodyPr wrap="square">
-            <a:spAutoFit/>
-          </a:bodyPr>
-          <a:lstStyle/>
-          <a:p>
-            <a:pPr>
-              <a:defRPr sz="3400" b="1">
-                <a:solidFill>
-                  <a:srgbClr val="1B3A5C"/>
-                </a:solidFill>
-              </a:defRPr>
-            </a:pPr>
-            <a:r>
-              <a:t>What's next</a:t>
-            </a:r>
-          </a:p>
-        </p:txBody>
-      </p:sp>
-      <p:sp>
-        <p:nvSpPr>
-          <p:cNvPr id="3" name="Rectangle 2"/>
+          <p:cNvPr id="2" name="Rectangle 1"/>
           <p:cNvSpPr/>
           <p:nvPr/>
         </p:nvSpPr>
         <p:spPr>
           <a:xfrm>
-            <a:off x="640080" y="1325880"/>
-            <a:ext cx="1463040" cy="54864"/>
+            <a:off x="0" y="0"/>
+            <a:ext cx="12191695" cy="6858000"/>
           </a:xfrm>
           <a:prstGeom prst="rect">
             <a:avLst/>
           </a:prstGeom>
           <a:solidFill>
-            <a:srgbClr val="0E7C86"/>
+            <a:srgbClr val="1B3A5C"/>
           </a:solidFill>
           <a:ln>
             <a:noFill/>
@@ -6498,14 +6675,14 @@
       </p:sp>
       <p:sp>
         <p:nvSpPr>
-          <p:cNvPr id="4" name="TextBox 3"/>
+          <p:cNvPr id="3" name="TextBox 2"/>
           <p:cNvSpPr txBox="1"/>
           <p:nvPr/>
         </p:nvSpPr>
         <p:spPr>
           <a:xfrm>
-            <a:off x="777240" y="2103120"/>
-            <a:ext cx="10607040" cy="4206240"/>
+            <a:off x="1097280" y="2651760"/>
+            <a:ext cx="10058400" cy="1463040"/>
           </a:xfrm>
           <a:prstGeom prst="rect">
             <a:avLst/>
@@ -6519,101 +6696,29 @@
           <a:lstStyle/>
           <a:p>
             <a:pPr>
-              <a:spcAft>
-                <a:spcPts val="1200"/>
-              </a:spcAft>
-              <a:defRPr sz="2100">
-                <a:solidFill>
-                  <a:srgbClr val="22262B"/>
+              <a:defRPr sz="4000" b="1">
+                <a:solidFill>
+                  <a:srgbClr val="FFFFFF"/>
                 </a:solidFill>
               </a:defRPr>
             </a:pPr>
             <a:r>
-              <a:t>• Broaden the index with additional assays:</a:t>
-            </a:r>
-          </a:p>
-          <a:p>
-            <a:pPr lvl="1">
+              <a:t>Use #2 — Real-time stress on the farm</a:t>
+            </a:r>
+          </a:p>
+          <a:p>
+            <a:pPr>
               <a:spcBef>
-                <a:spcPts val="200"/>
+                <a:spcPts val="1000"/>
               </a:spcBef>
-              <a:spcAft>
-                <a:spcPts val="1200"/>
-              </a:spcAft>
-              <a:defRPr sz="1700">
-                <a:solidFill>
-                  <a:srgbClr val="444A52"/>
+              <a:defRPr sz="2000">
+                <a:solidFill>
+                  <a:srgbClr val="9FD3D8"/>
                 </a:solidFill>
               </a:defRPr>
             </a:pPr>
             <a:r>
-              <a:t>– Glycogen (heat vs. control, 3 h)</a:t>
-            </a:r>
-          </a:p>
-          <a:p>
-            <a:pPr lvl="1">
-              <a:spcBef>
-                <a:spcPts val="200"/>
-              </a:spcBef>
-              <a:spcAft>
-                <a:spcPts val="1200"/>
-              </a:spcAft>
-              <a:defRPr sz="1700">
-                <a:solidFill>
-                  <a:srgbClr val="444A52"/>
-                </a:solidFill>
-              </a:defRPr>
-            </a:pPr>
-            <a:r>
-              <a:t>– Na+/K+ ATPase</a:t>
-            </a:r>
-          </a:p>
-          <a:p>
-            <a:pPr lvl="1">
-              <a:spcBef>
-                <a:spcPts val="200"/>
-              </a:spcBef>
-              <a:spcAft>
-                <a:spcPts val="1200"/>
-              </a:spcAft>
-              <a:defRPr sz="1700">
-                <a:solidFill>
-                  <a:srgbClr val="444A52"/>
-                </a:solidFill>
-              </a:defRPr>
-            </a:pPr>
-            <a:r>
-              <a:t>– Citrate synthase</a:t>
-            </a:r>
-          </a:p>
-          <a:p>
-            <a:pPr>
-              <a:spcAft>
-                <a:spcPts val="1200"/>
-              </a:spcAft>
-              <a:defRPr sz="2100">
-                <a:solidFill>
-                  <a:srgbClr val="22262B"/>
-                </a:solidFill>
-              </a:defRPr>
-            </a:pPr>
-            <a:r>
-              <a:t>• Validate predictions against field outplants across PNW sites.</a:t>
-            </a:r>
-          </a:p>
-          <a:p>
-            <a:pPr>
-              <a:spcAft>
-                <a:spcPts val="1200"/>
-              </a:spcAft>
-              <a:defRPr sz="2100">
-                <a:solidFill>
-                  <a:srgbClr val="22262B"/>
-                </a:solidFill>
-              </a:defRPr>
-            </a:pPr>
-            <a:r>
-              <a:t>• Package a grower-facing protocol and a simple scoring sheet.</a:t>
+              <a:t>A thermometer for physiological condition</a:t>
             </a:r>
           </a:p>
         </p:txBody>
@@ -6666,7 +6771,7 @@
               </a:defRPr>
             </a:pPr>
             <a:r>
-              <a:t>Takeaways</a:t>
+              <a:t>Reading stress while it's happening</a:t>
             </a:r>
           </a:p>
         </p:txBody>
@@ -6723,8 +6828,8 @@
         </p:nvSpPr>
         <p:spPr>
           <a:xfrm>
-            <a:off x="777240" y="2194560"/>
-            <a:ext cx="10607040" cy="4206240"/>
+            <a:off x="640080" y="1463040"/>
+            <a:ext cx="10881360" cy="457200"/>
           </a:xfrm>
           <a:prstGeom prst="rect">
             <a:avLst/>
@@ -6738,69 +6843,119 @@
           <a:lstStyle/>
           <a:p>
             <a:pPr>
-              <a:spcAft>
-                <a:spcPts val="2200"/>
-              </a:spcAft>
-              <a:defRPr sz="2200">
-                <a:solidFill>
-                  <a:srgbClr val="22262B"/>
+              <a:defRPr sz="1800" i="1">
+                <a:solidFill>
+                  <a:srgbClr val="0E7C86"/>
                 </a:solidFill>
               </a:defRPr>
             </a:pPr>
             <a:r>
-              <a:t>• Resazurin turns metabolism into a color change — cheap, non-lethal, 96 animals at a time.</a:t>
-            </a:r>
-          </a:p>
+              <a:t>Same assay, different question</a:t>
+            </a:r>
+          </a:p>
+        </p:txBody>
+      </p:sp>
+      <p:sp>
+        <p:nvSpPr>
+          <p:cNvPr id="5" name="TextBox 4"/>
+          <p:cNvSpPr txBox="1"/>
+          <p:nvPr/>
+        </p:nvSpPr>
+        <p:spPr>
+          <a:xfrm>
+            <a:off x="777240" y="2148840"/>
+            <a:ext cx="10607040" cy="4206240"/>
+          </a:xfrm>
+          <a:prstGeom prst="rect">
+            <a:avLst/>
+          </a:prstGeom>
+          <a:noFill/>
+        </p:spPr>
+        <p:txBody>
+          <a:bodyPr wrap="square">
+            <a:spAutoFit/>
+          </a:bodyPr>
+          <a:lstStyle/>
           <a:p>
             <a:pPr>
               <a:spcAft>
-                <a:spcPts val="2200"/>
+                <a:spcPts val="1600"/>
               </a:spcAft>
-              <a:defRPr sz="2200">
+              <a:defRPr sz="2100">
                 <a:solidFill>
                   <a:srgbClr val="22262B"/>
                 </a:solidFill>
               </a:defRPr>
             </a:pPr>
             <a:r>
-              <a:t>• Published and validated against oxygen consumption (PeerJ 2026).</a:t>
+              <a:t>• Pull a small sample of animals, run a plate, get an answer the same day.</a:t>
             </a:r>
           </a:p>
           <a:p>
             <a:pPr>
               <a:spcAft>
-                <a:spcPts val="2200"/>
+                <a:spcPts val="1600"/>
               </a:spcAft>
-              <a:defRPr sz="2200">
+              <a:defRPr sz="2100">
                 <a:solidFill>
                   <a:srgbClr val="22262B"/>
                 </a:solidFill>
               </a:defRPr>
             </a:pPr>
             <a:r>
-              <a:t>• Predicts phenotype: metabolic curve shape forecasts family hardiness (cross-validated rho ≈ 0.8).</a:t>
+              <a:t>• Elevated metabolism under a heat or salinity event flags a crop under load — before mortality shows up.</a:t>
             </a:r>
           </a:p>
           <a:p>
             <a:pPr>
               <a:spcAft>
-                <a:spcPts val="2200"/>
+                <a:spcPts val="1600"/>
               </a:spcAft>
-              <a:defRPr sz="2200">
+              <a:defRPr sz="2100">
                 <a:solidFill>
                   <a:srgbClr val="22262B"/>
                 </a:solidFill>
               </a:defRPr>
             </a:pPr>
             <a:r>
-              <a:t>• Measures stress in real time: a same-day readout of how hard your crop is working.</a:t>
-            </a:r>
-          </a:p>
-        </p:txBody>
-      </p:sp>
-      <p:sp>
-        <p:nvSpPr>
-          <p:cNvPr id="5" name="Rectangle 4"/>
+              <a:t>• Compare bags, tidal heights, gear types, or sites on the same afternoon.</a:t>
+            </a:r>
+          </a:p>
+          <a:p>
+            <a:pPr>
+              <a:spcAft>
+                <a:spcPts val="1600"/>
+              </a:spcAft>
+              <a:defRPr sz="2100">
+                <a:solidFill>
+                  <a:srgbClr val="22262B"/>
+                </a:solidFill>
+              </a:defRPr>
+            </a:pPr>
+            <a:r>
+              <a:t>• Track recovery after an event: does metabolism return to baseline, and how fast?</a:t>
+            </a:r>
+          </a:p>
+          <a:p>
+            <a:pPr>
+              <a:spcAft>
+                <a:spcPts val="1600"/>
+              </a:spcAft>
+              <a:defRPr sz="2100">
+                <a:solidFill>
+                  <a:srgbClr val="22262B"/>
+                </a:solidFill>
+              </a:defRPr>
+            </a:pPr>
+            <a:r>
+              <a:t>• Non-lethal and cheap enough to repeat weekly through a risky season.</a:t>
+            </a:r>
+          </a:p>
+        </p:txBody>
+      </p:sp>
+      <p:sp>
+        <p:nvSpPr>
+          <p:cNvPr id="6" name="Rectangle 5"/>
           <p:cNvSpPr/>
           <p:nvPr/>
         </p:nvSpPr>
@@ -6817,7 +6972,7 @@
           </a:solidFill>
           <a:ln w="15875">
             <a:solidFill>
-              <a:srgbClr val="0E7C86"/>
+              <a:srgbClr val="C2187A"/>
             </a:solidFill>
           </a:ln>
           <a:effectLst/>
@@ -6848,7 +7003,226 @@
               </a:defRPr>
             </a:pPr>
             <a:r>
-              <a:t>FUNDING  - USDA-WRAC - sormi.science</a:t>
+              <a:t>Turns "the water got hot last week" into a number you can act on.</a:t>
+            </a:r>
+          </a:p>
+        </p:txBody>
+      </p:sp>
+    </p:spTree>
+  </p:cSld>
+  <p:clrMapOvr>
+    <a:masterClrMapping/>
+  </p:clrMapOvr>
+</p:sld>
+</file>
+
+<file path=ppt/slides/slide19.xml><?xml version="1.0" encoding="utf-8"?>
+<p:sld xmlns:a="http://schemas.openxmlformats.org/drawingml/2006/main" xmlns:p="http://schemas.openxmlformats.org/presentationml/2006/main" xmlns:r="http://schemas.openxmlformats.org/officeDocument/2006/relationships">
+  <p:cSld>
+    <p:spTree>
+      <p:nvGrpSpPr>
+        <p:cNvPr id="1" name=""/>
+        <p:cNvGrpSpPr/>
+        <p:nvPr/>
+      </p:nvGrpSpPr>
+      <p:grpSpPr/>
+      <p:sp>
+        <p:nvSpPr>
+          <p:cNvPr id="2" name="TextBox 1"/>
+          <p:cNvSpPr txBox="1"/>
+          <p:nvPr/>
+        </p:nvSpPr>
+        <p:spPr>
+          <a:xfrm>
+            <a:off x="640080" y="411480"/>
+            <a:ext cx="10881360" cy="914400"/>
+          </a:xfrm>
+          <a:prstGeom prst="rect">
+            <a:avLst/>
+          </a:prstGeom>
+          <a:noFill/>
+        </p:spPr>
+        <p:txBody>
+          <a:bodyPr wrap="square">
+            <a:spAutoFit/>
+          </a:bodyPr>
+          <a:lstStyle/>
+          <a:p>
+            <a:pPr>
+              <a:defRPr sz="3400" b="1">
+                <a:solidFill>
+                  <a:srgbClr val="1B3A5C"/>
+                </a:solidFill>
+              </a:defRPr>
+            </a:pPr>
+            <a:r>
+              <a:t>What's next</a:t>
+            </a:r>
+          </a:p>
+        </p:txBody>
+      </p:sp>
+      <p:sp>
+        <p:nvSpPr>
+          <p:cNvPr id="3" name="Rectangle 2"/>
+          <p:cNvSpPr/>
+          <p:nvPr/>
+        </p:nvSpPr>
+        <p:spPr>
+          <a:xfrm>
+            <a:off x="640080" y="1325880"/>
+            <a:ext cx="1463040" cy="54864"/>
+          </a:xfrm>
+          <a:prstGeom prst="rect">
+            <a:avLst/>
+          </a:prstGeom>
+          <a:solidFill>
+            <a:srgbClr val="0E7C86"/>
+          </a:solidFill>
+          <a:ln>
+            <a:noFill/>
+          </a:ln>
+          <a:effectLst/>
+        </p:spPr>
+        <p:style>
+          <a:lnRef idx="1">
+            <a:schemeClr val="accent1"/>
+          </a:lnRef>
+          <a:fillRef idx="3">
+            <a:schemeClr val="accent1"/>
+          </a:fillRef>
+          <a:effectRef idx="2">
+            <a:schemeClr val="accent1"/>
+          </a:effectRef>
+          <a:fontRef idx="minor">
+            <a:schemeClr val="lt1"/>
+          </a:fontRef>
+        </p:style>
+        <p:txBody>
+          <a:bodyPr rtlCol="0" anchor="ctr"/>
+          <a:lstStyle/>
+          <a:p>
+            <a:pPr algn="ctr"/>
+          </a:p>
+        </p:txBody>
+      </p:sp>
+      <p:sp>
+        <p:nvSpPr>
+          <p:cNvPr id="4" name="TextBox 3"/>
+          <p:cNvSpPr txBox="1"/>
+          <p:nvPr/>
+        </p:nvSpPr>
+        <p:spPr>
+          <a:xfrm>
+            <a:off x="777240" y="2103120"/>
+            <a:ext cx="10607040" cy="4206240"/>
+          </a:xfrm>
+          <a:prstGeom prst="rect">
+            <a:avLst/>
+          </a:prstGeom>
+          <a:noFill/>
+        </p:spPr>
+        <p:txBody>
+          <a:bodyPr wrap="square">
+            <a:spAutoFit/>
+          </a:bodyPr>
+          <a:lstStyle/>
+          <a:p>
+            <a:pPr>
+              <a:spcAft>
+                <a:spcPts val="1200"/>
+              </a:spcAft>
+              <a:defRPr sz="2100">
+                <a:solidFill>
+                  <a:srgbClr val="22262B"/>
+                </a:solidFill>
+              </a:defRPr>
+            </a:pPr>
+            <a:r>
+              <a:t>• Broaden the index with additional assays:</a:t>
+            </a:r>
+          </a:p>
+          <a:p>
+            <a:pPr lvl="1">
+              <a:spcBef>
+                <a:spcPts val="200"/>
+              </a:spcBef>
+              <a:spcAft>
+                <a:spcPts val="1200"/>
+              </a:spcAft>
+              <a:defRPr sz="1700">
+                <a:solidFill>
+                  <a:srgbClr val="444A52"/>
+                </a:solidFill>
+              </a:defRPr>
+            </a:pPr>
+            <a:r>
+              <a:t>– Glycogen (heat vs. control, 3 h)</a:t>
+            </a:r>
+          </a:p>
+          <a:p>
+            <a:pPr lvl="1">
+              <a:spcBef>
+                <a:spcPts val="200"/>
+              </a:spcBef>
+              <a:spcAft>
+                <a:spcPts val="1200"/>
+              </a:spcAft>
+              <a:defRPr sz="1700">
+                <a:solidFill>
+                  <a:srgbClr val="444A52"/>
+                </a:solidFill>
+              </a:defRPr>
+            </a:pPr>
+            <a:r>
+              <a:t>– Na+/K+ ATPase</a:t>
+            </a:r>
+          </a:p>
+          <a:p>
+            <a:pPr lvl="1">
+              <a:spcBef>
+                <a:spcPts val="200"/>
+              </a:spcBef>
+              <a:spcAft>
+                <a:spcPts val="1200"/>
+              </a:spcAft>
+              <a:defRPr sz="1700">
+                <a:solidFill>
+                  <a:srgbClr val="444A52"/>
+                </a:solidFill>
+              </a:defRPr>
+            </a:pPr>
+            <a:r>
+              <a:t>– Citrate synthase</a:t>
+            </a:r>
+          </a:p>
+          <a:p>
+            <a:pPr>
+              <a:spcAft>
+                <a:spcPts val="1200"/>
+              </a:spcAft>
+              <a:defRPr sz="2100">
+                <a:solidFill>
+                  <a:srgbClr val="22262B"/>
+                </a:solidFill>
+              </a:defRPr>
+            </a:pPr>
+            <a:r>
+              <a:t>• Validate predictions against field outplants across PNW sites.</a:t>
+            </a:r>
+          </a:p>
+          <a:p>
+            <a:pPr>
+              <a:spcAft>
+                <a:spcPts val="1200"/>
+              </a:spcAft>
+              <a:defRPr sz="2100">
+                <a:solidFill>
+                  <a:srgbClr val="22262B"/>
+                </a:solidFill>
+              </a:defRPr>
+            </a:pPr>
+            <a:r>
+              <a:t>• Package a grower-facing protocol and a simple scoring sheet.</a:t>
             </a:r>
           </a:p>
         </p:txBody>
@@ -7104,6 +7478,241 @@
             </a:pPr>
             <a:r>
               <a:t>We need a fast, cheap, non-lethal measure of how an oyster is doing — right now.</a:t>
+            </a:r>
+          </a:p>
+        </p:txBody>
+      </p:sp>
+    </p:spTree>
+  </p:cSld>
+  <p:clrMapOvr>
+    <a:masterClrMapping/>
+  </p:clrMapOvr>
+</p:sld>
+</file>
+
+<file path=ppt/slides/slide20.xml><?xml version="1.0" encoding="utf-8"?>
+<p:sld xmlns:a="http://schemas.openxmlformats.org/drawingml/2006/main" xmlns:p="http://schemas.openxmlformats.org/presentationml/2006/main" xmlns:r="http://schemas.openxmlformats.org/officeDocument/2006/relationships">
+  <p:cSld>
+    <p:spTree>
+      <p:nvGrpSpPr>
+        <p:cNvPr id="1" name=""/>
+        <p:cNvGrpSpPr/>
+        <p:nvPr/>
+      </p:nvGrpSpPr>
+      <p:grpSpPr/>
+      <p:sp>
+        <p:nvSpPr>
+          <p:cNvPr id="2" name="TextBox 1"/>
+          <p:cNvSpPr txBox="1"/>
+          <p:nvPr/>
+        </p:nvSpPr>
+        <p:spPr>
+          <a:xfrm>
+            <a:off x="640080" y="411480"/>
+            <a:ext cx="10881360" cy="914400"/>
+          </a:xfrm>
+          <a:prstGeom prst="rect">
+            <a:avLst/>
+          </a:prstGeom>
+          <a:noFill/>
+        </p:spPr>
+        <p:txBody>
+          <a:bodyPr wrap="square">
+            <a:spAutoFit/>
+          </a:bodyPr>
+          <a:lstStyle/>
+          <a:p>
+            <a:pPr>
+              <a:defRPr sz="3400" b="1">
+                <a:solidFill>
+                  <a:srgbClr val="1B3A5C"/>
+                </a:solidFill>
+              </a:defRPr>
+            </a:pPr>
+            <a:r>
+              <a:t>Takeaways</a:t>
+            </a:r>
+          </a:p>
+        </p:txBody>
+      </p:sp>
+      <p:sp>
+        <p:nvSpPr>
+          <p:cNvPr id="3" name="Rectangle 2"/>
+          <p:cNvSpPr/>
+          <p:nvPr/>
+        </p:nvSpPr>
+        <p:spPr>
+          <a:xfrm>
+            <a:off x="640080" y="1325880"/>
+            <a:ext cx="1463040" cy="54864"/>
+          </a:xfrm>
+          <a:prstGeom prst="rect">
+            <a:avLst/>
+          </a:prstGeom>
+          <a:solidFill>
+            <a:srgbClr val="0E7C86"/>
+          </a:solidFill>
+          <a:ln>
+            <a:noFill/>
+          </a:ln>
+          <a:effectLst/>
+        </p:spPr>
+        <p:style>
+          <a:lnRef idx="1">
+            <a:schemeClr val="accent1"/>
+          </a:lnRef>
+          <a:fillRef idx="3">
+            <a:schemeClr val="accent1"/>
+          </a:fillRef>
+          <a:effectRef idx="2">
+            <a:schemeClr val="accent1"/>
+          </a:effectRef>
+          <a:fontRef idx="minor">
+            <a:schemeClr val="lt1"/>
+          </a:fontRef>
+        </p:style>
+        <p:txBody>
+          <a:bodyPr rtlCol="0" anchor="ctr"/>
+          <a:lstStyle/>
+          <a:p>
+            <a:pPr algn="ctr"/>
+          </a:p>
+        </p:txBody>
+      </p:sp>
+      <p:sp>
+        <p:nvSpPr>
+          <p:cNvPr id="4" name="TextBox 3"/>
+          <p:cNvSpPr txBox="1"/>
+          <p:nvPr/>
+        </p:nvSpPr>
+        <p:spPr>
+          <a:xfrm>
+            <a:off x="777240" y="2194560"/>
+            <a:ext cx="10607040" cy="4206240"/>
+          </a:xfrm>
+          <a:prstGeom prst="rect">
+            <a:avLst/>
+          </a:prstGeom>
+          <a:noFill/>
+        </p:spPr>
+        <p:txBody>
+          <a:bodyPr wrap="square">
+            <a:spAutoFit/>
+          </a:bodyPr>
+          <a:lstStyle/>
+          <a:p>
+            <a:pPr>
+              <a:spcAft>
+                <a:spcPts val="2200"/>
+              </a:spcAft>
+              <a:defRPr sz="2200">
+                <a:solidFill>
+                  <a:srgbClr val="22262B"/>
+                </a:solidFill>
+              </a:defRPr>
+            </a:pPr>
+            <a:r>
+              <a:t>• Resazurin turns metabolism into a color change — cheap, non-lethal, 96 animals at a time.</a:t>
+            </a:r>
+          </a:p>
+          <a:p>
+            <a:pPr>
+              <a:spcAft>
+                <a:spcPts val="2200"/>
+              </a:spcAft>
+              <a:defRPr sz="2200">
+                <a:solidFill>
+                  <a:srgbClr val="22262B"/>
+                </a:solidFill>
+              </a:defRPr>
+            </a:pPr>
+            <a:r>
+              <a:t>• Published and validated against oxygen consumption (PeerJ 2026).</a:t>
+            </a:r>
+          </a:p>
+          <a:p>
+            <a:pPr>
+              <a:spcAft>
+                <a:spcPts val="2200"/>
+              </a:spcAft>
+              <a:defRPr sz="2200">
+                <a:solidFill>
+                  <a:srgbClr val="22262B"/>
+                </a:solidFill>
+              </a:defRPr>
+            </a:pPr>
+            <a:r>
+              <a:t>• Predicts phenotype: metabolic curve shape forecasts family hardiness (cross-validated rho ≈ 0.8).</a:t>
+            </a:r>
+          </a:p>
+          <a:p>
+            <a:pPr>
+              <a:spcAft>
+                <a:spcPts val="2200"/>
+              </a:spcAft>
+              <a:defRPr sz="2200">
+                <a:solidFill>
+                  <a:srgbClr val="22262B"/>
+                </a:solidFill>
+              </a:defRPr>
+            </a:pPr>
+            <a:r>
+              <a:t>• Measures stress in real time: a same-day readout of how hard your crop is working.</a:t>
+            </a:r>
+          </a:p>
+        </p:txBody>
+      </p:sp>
+      <p:sp>
+        <p:nvSpPr>
+          <p:cNvPr id="5" name="Rectangle 4"/>
+          <p:cNvSpPr/>
+          <p:nvPr/>
+        </p:nvSpPr>
+        <p:spPr>
+          <a:xfrm>
+            <a:off x="777240" y="5623560"/>
+            <a:ext cx="10607040" cy="777240"/>
+          </a:xfrm>
+          <a:prstGeom prst="rect">
+            <a:avLst/>
+          </a:prstGeom>
+          <a:solidFill>
+            <a:srgbClr val="EFF3F6"/>
+          </a:solidFill>
+          <a:ln w="15875">
+            <a:solidFill>
+              <a:srgbClr val="0E7C86"/>
+            </a:solidFill>
+          </a:ln>
+          <a:effectLst/>
+        </p:spPr>
+        <p:style>
+          <a:lnRef idx="1">
+            <a:schemeClr val="accent1"/>
+          </a:lnRef>
+          <a:fillRef idx="3">
+            <a:schemeClr val="accent1"/>
+          </a:fillRef>
+          <a:effectRef idx="2">
+            <a:schemeClr val="accent1"/>
+          </a:effectRef>
+          <a:fontRef idx="minor">
+            <a:schemeClr val="lt1"/>
+          </a:fontRef>
+        </p:style>
+        <p:txBody>
+          <a:bodyPr rtlCol="0" anchor="ctr" wrap="square"/>
+          <a:lstStyle/>
+          <a:p>
+            <a:pPr algn="ctr">
+              <a:defRPr sz="1900" b="1">
+                <a:solidFill>
+                  <a:srgbClr val="1B3A5C"/>
+                </a:solidFill>
+              </a:defRPr>
+            </a:pPr>
+            <a:r>
+              <a:t>FUNDING  - USDA-WRAC - sormi.science</a:t>
             </a:r>
           </a:p>
         </p:txBody>

</xml_diff>